<commit_message>
new post - commencement
</commit_message>
<xml_diff>
--- a/_site/assets/img/presentation/match_size.pptx
+++ b/_site/assets/img/presentation/match_size.pptx
@@ -7,6 +7,7 @@
   <p:sldIdLst>
     <p:sldId id="256" r:id="rId2"/>
     <p:sldId id="257" r:id="rId3"/>
+    <p:sldId id="258" r:id="rId4"/>
   </p:sldIdLst>
   <p:sldSz cx="12192000" cy="6858000"/>
   <p:notesSz cx="6858000" cy="9144000"/>
@@ -262,7 +263,7 @@
           <a:p>
             <a:fld id="{8AB6B10D-0C63-4246-8458-3B1752B4C5D8}" type="datetimeFigureOut">
               <a:rPr lang="en-KR" smtClean="0"/>
-              <a:t>2020/12/02</a:t>
+              <a:t>2021/07/29</a:t>
             </a:fld>
             <a:endParaRPr lang="en-KR"/>
           </a:p>
@@ -462,7 +463,7 @@
           <a:p>
             <a:fld id="{8AB6B10D-0C63-4246-8458-3B1752B4C5D8}" type="datetimeFigureOut">
               <a:rPr lang="en-KR" smtClean="0"/>
-              <a:t>2020/12/02</a:t>
+              <a:t>2021/07/29</a:t>
             </a:fld>
             <a:endParaRPr lang="en-KR"/>
           </a:p>
@@ -672,7 +673,7 @@
           <a:p>
             <a:fld id="{8AB6B10D-0C63-4246-8458-3B1752B4C5D8}" type="datetimeFigureOut">
               <a:rPr lang="en-KR" smtClean="0"/>
-              <a:t>2020/12/02</a:t>
+              <a:t>2021/07/29</a:t>
             </a:fld>
             <a:endParaRPr lang="en-KR"/>
           </a:p>
@@ -872,7 +873,7 @@
           <a:p>
             <a:fld id="{8AB6B10D-0C63-4246-8458-3B1752B4C5D8}" type="datetimeFigureOut">
               <a:rPr lang="en-KR" smtClean="0"/>
-              <a:t>2020/12/02</a:t>
+              <a:t>2021/07/29</a:t>
             </a:fld>
             <a:endParaRPr lang="en-KR"/>
           </a:p>
@@ -1148,7 +1149,7 @@
           <a:p>
             <a:fld id="{8AB6B10D-0C63-4246-8458-3B1752B4C5D8}" type="datetimeFigureOut">
               <a:rPr lang="en-KR" smtClean="0"/>
-              <a:t>2020/12/02</a:t>
+              <a:t>2021/07/29</a:t>
             </a:fld>
             <a:endParaRPr lang="en-KR"/>
           </a:p>
@@ -1416,7 +1417,7 @@
           <a:p>
             <a:fld id="{8AB6B10D-0C63-4246-8458-3B1752B4C5D8}" type="datetimeFigureOut">
               <a:rPr lang="en-KR" smtClean="0"/>
-              <a:t>2020/12/02</a:t>
+              <a:t>2021/07/29</a:t>
             </a:fld>
             <a:endParaRPr lang="en-KR"/>
           </a:p>
@@ -1831,7 +1832,7 @@
           <a:p>
             <a:fld id="{8AB6B10D-0C63-4246-8458-3B1752B4C5D8}" type="datetimeFigureOut">
               <a:rPr lang="en-KR" smtClean="0"/>
-              <a:t>2020/12/02</a:t>
+              <a:t>2021/07/29</a:t>
             </a:fld>
             <a:endParaRPr lang="en-KR"/>
           </a:p>
@@ -1973,7 +1974,7 @@
           <a:p>
             <a:fld id="{8AB6B10D-0C63-4246-8458-3B1752B4C5D8}" type="datetimeFigureOut">
               <a:rPr lang="en-KR" smtClean="0"/>
-              <a:t>2020/12/02</a:t>
+              <a:t>2021/07/29</a:t>
             </a:fld>
             <a:endParaRPr lang="en-KR"/>
           </a:p>
@@ -2086,7 +2087,7 @@
           <a:p>
             <a:fld id="{8AB6B10D-0C63-4246-8458-3B1752B4C5D8}" type="datetimeFigureOut">
               <a:rPr lang="en-KR" smtClean="0"/>
-              <a:t>2020/12/02</a:t>
+              <a:t>2021/07/29</a:t>
             </a:fld>
             <a:endParaRPr lang="en-KR"/>
           </a:p>
@@ -2399,7 +2400,7 @@
           <a:p>
             <a:fld id="{8AB6B10D-0C63-4246-8458-3B1752B4C5D8}" type="datetimeFigureOut">
               <a:rPr lang="en-KR" smtClean="0"/>
-              <a:t>2020/12/02</a:t>
+              <a:t>2021/07/29</a:t>
             </a:fld>
             <a:endParaRPr lang="en-KR"/>
           </a:p>
@@ -2688,7 +2689,7 @@
           <a:p>
             <a:fld id="{8AB6B10D-0C63-4246-8458-3B1752B4C5D8}" type="datetimeFigureOut">
               <a:rPr lang="en-KR" smtClean="0"/>
-              <a:t>2020/12/02</a:t>
+              <a:t>2021/07/29</a:t>
             </a:fld>
             <a:endParaRPr lang="en-KR"/>
           </a:p>
@@ -2931,7 +2932,7 @@
           <a:p>
             <a:fld id="{8AB6B10D-0C63-4246-8458-3B1752B4C5D8}" type="datetimeFigureOut">
               <a:rPr lang="en-KR" smtClean="0"/>
-              <a:t>2020/12/02</a:t>
+              <a:t>2021/07/29</a:t>
             </a:fld>
             <a:endParaRPr lang="en-KR"/>
           </a:p>
@@ -3350,10 +3351,10 @@
       </p:grpSpPr>
       <p:pic>
         <p:nvPicPr>
-          <p:cNvPr id="6" name="Picture 5">
-            <a:extLst>
-              <a:ext uri="{FF2B5EF4-FFF2-40B4-BE49-F238E27FC236}">
-                <a16:creationId xmlns:a16="http://schemas.microsoft.com/office/drawing/2014/main" id="{73F2C1AB-A7A8-704B-9C06-C1144FC5569A}"/>
+          <p:cNvPr id="3" name="Picture 2">
+            <a:extLst>
+              <a:ext uri="{FF2B5EF4-FFF2-40B4-BE49-F238E27FC236}">
+                <a16:creationId xmlns:a16="http://schemas.microsoft.com/office/drawing/2014/main" id="{C8C39007-8948-6E45-8762-CD0953BFD41C}"/>
               </a:ext>
             </a:extLst>
           </p:cNvPr>
@@ -3370,72 +3371,7 @@
         </p:blipFill>
         <p:spPr>
           <a:xfrm>
-            <a:off x="2407508" y="345054"/>
-            <a:ext cx="5715000" cy="4127500"/>
-          </a:xfrm>
-          <a:prstGeom prst="rect">
-            <a:avLst/>
-          </a:prstGeom>
-          <a:ln>
-            <a:solidFill>
-              <a:schemeClr val="accent1"/>
-            </a:solidFill>
-          </a:ln>
-        </p:spPr>
-      </p:pic>
-      <p:pic>
-        <p:nvPicPr>
-          <p:cNvPr id="2" name="Picture 1">
-            <a:extLst>
-              <a:ext uri="{FF2B5EF4-FFF2-40B4-BE49-F238E27FC236}">
-                <a16:creationId xmlns:a16="http://schemas.microsoft.com/office/drawing/2014/main" id="{1DA6BBE2-4C8E-E541-BB52-C74B5A043CB6}"/>
-              </a:ext>
-            </a:extLst>
-          </p:cNvPr>
-          <p:cNvPicPr>
-            <a:picLocks noChangeAspect="1"/>
-          </p:cNvPicPr>
-          <p:nvPr/>
-        </p:nvPicPr>
-        <p:blipFill>
-          <a:blip r:embed="rId3"/>
-          <a:stretch>
-            <a:fillRect/>
-          </a:stretch>
-        </p:blipFill>
-        <p:spPr>
-          <a:xfrm>
-            <a:off x="2413858" y="821933"/>
-            <a:ext cx="5708650" cy="3066218"/>
-          </a:xfrm>
-          <a:prstGeom prst="rect">
-            <a:avLst/>
-          </a:prstGeom>
-        </p:spPr>
-      </p:pic>
-      <p:pic>
-        <p:nvPicPr>
-          <p:cNvPr id="3" name="Picture 2">
-            <a:extLst>
-              <a:ext uri="{FF2B5EF4-FFF2-40B4-BE49-F238E27FC236}">
-                <a16:creationId xmlns:a16="http://schemas.microsoft.com/office/drawing/2014/main" id="{C8C39007-8948-6E45-8762-CD0953BFD41C}"/>
-              </a:ext>
-            </a:extLst>
-          </p:cNvPr>
-          <p:cNvPicPr>
-            <a:picLocks noChangeAspect="1"/>
-          </p:cNvPicPr>
-          <p:nvPr/>
-        </p:nvPicPr>
-        <p:blipFill>
-          <a:blip r:embed="rId4"/>
-          <a:stretch>
-            <a:fillRect/>
-          </a:stretch>
-        </p:blipFill>
-        <p:spPr>
-          <a:xfrm>
-            <a:off x="6513814" y="2651515"/>
+            <a:off x="8671388" y="3237142"/>
             <a:ext cx="5174751" cy="2904786"/>
           </a:xfrm>
           <a:prstGeom prst="rect">
@@ -3443,6 +3379,120 @@
           </a:prstGeom>
         </p:spPr>
       </p:pic>
+      <p:grpSp>
+        <p:nvGrpSpPr>
+          <p:cNvPr id="4" name="Group 3">
+            <a:extLst>
+              <a:ext uri="{FF2B5EF4-FFF2-40B4-BE49-F238E27FC236}">
+                <a16:creationId xmlns:a16="http://schemas.microsoft.com/office/drawing/2014/main" id="{6F0724BD-FF7C-4F4E-A75D-B556FF94FE0F}"/>
+              </a:ext>
+            </a:extLst>
+          </p:cNvPr>
+          <p:cNvGrpSpPr/>
+          <p:nvPr/>
+        </p:nvGrpSpPr>
+        <p:grpSpPr>
+          <a:xfrm>
+            <a:off x="2406661" y="345054"/>
+            <a:ext cx="5715847" cy="4127500"/>
+            <a:chOff x="2406661" y="345054"/>
+            <a:chExt cx="5715847" cy="4127500"/>
+          </a:xfrm>
+        </p:grpSpPr>
+        <p:pic>
+          <p:nvPicPr>
+            <p:cNvPr id="6" name="Picture 5">
+              <a:extLst>
+                <a:ext uri="{FF2B5EF4-FFF2-40B4-BE49-F238E27FC236}">
+                  <a16:creationId xmlns:a16="http://schemas.microsoft.com/office/drawing/2014/main" id="{73F2C1AB-A7A8-704B-9C06-C1144FC5569A}"/>
+                </a:ext>
+              </a:extLst>
+            </p:cNvPr>
+            <p:cNvPicPr>
+              <a:picLocks noChangeAspect="1"/>
+            </p:cNvPicPr>
+            <p:nvPr/>
+          </p:nvPicPr>
+          <p:blipFill>
+            <a:blip r:embed="rId3"/>
+            <a:stretch>
+              <a:fillRect/>
+            </a:stretch>
+          </p:blipFill>
+          <p:spPr>
+            <a:xfrm>
+              <a:off x="2407508" y="345054"/>
+              <a:ext cx="5715000" cy="4127500"/>
+            </a:xfrm>
+            <a:prstGeom prst="rect">
+              <a:avLst/>
+            </a:prstGeom>
+            <a:ln>
+              <a:solidFill>
+                <a:schemeClr val="accent1"/>
+              </a:solidFill>
+            </a:ln>
+          </p:spPr>
+        </p:pic>
+        <p:pic>
+          <p:nvPicPr>
+            <p:cNvPr id="8" name="Picture 7">
+              <a:extLst>
+                <a:ext uri="{FF2B5EF4-FFF2-40B4-BE49-F238E27FC236}">
+                  <a16:creationId xmlns:a16="http://schemas.microsoft.com/office/drawing/2014/main" id="{1E4ED8F6-42DE-E148-8EE3-AF447D8E00C3}"/>
+                </a:ext>
+              </a:extLst>
+            </p:cNvPr>
+            <p:cNvPicPr>
+              <a:picLocks noChangeAspect="1"/>
+            </p:cNvPicPr>
+            <p:nvPr/>
+          </p:nvPicPr>
+          <p:blipFill rotWithShape="1">
+            <a:blip r:embed="rId4"/>
+            <a:srcRect l="1552" b="1150"/>
+            <a:stretch/>
+          </p:blipFill>
+          <p:spPr>
+            <a:xfrm>
+              <a:off x="2406661" y="803191"/>
+              <a:ext cx="5715847" cy="3231238"/>
+            </a:xfrm>
+            <a:prstGeom prst="rect">
+              <a:avLst/>
+            </a:prstGeom>
+          </p:spPr>
+        </p:pic>
+        <p:pic>
+          <p:nvPicPr>
+            <p:cNvPr id="5" name="Picture 4">
+              <a:extLst>
+                <a:ext uri="{FF2B5EF4-FFF2-40B4-BE49-F238E27FC236}">
+                  <a16:creationId xmlns:a16="http://schemas.microsoft.com/office/drawing/2014/main" id="{0D576881-7C6B-4C44-B0DB-E9143FDD41C6}"/>
+                </a:ext>
+              </a:extLst>
+            </p:cNvPr>
+            <p:cNvPicPr>
+              <a:picLocks noChangeAspect="1"/>
+            </p:cNvPicPr>
+            <p:nvPr/>
+          </p:nvPicPr>
+          <p:blipFill rotWithShape="1">
+            <a:blip r:embed="rId5"/>
+            <a:srcRect t="2517" r="2174"/>
+            <a:stretch/>
+          </p:blipFill>
+          <p:spPr>
+            <a:xfrm>
+              <a:off x="2406661" y="803191"/>
+              <a:ext cx="5715000" cy="3231238"/>
+            </a:xfrm>
+            <a:prstGeom prst="rect">
+              <a:avLst/>
+            </a:prstGeom>
+          </p:spPr>
+        </p:pic>
+      </p:grpSp>
     </p:spTree>
     <p:extLst>
       <p:ext uri="{BB962C8B-B14F-4D97-AF65-F5344CB8AC3E}">
@@ -3475,10 +3525,10 @@
       </p:grpSpPr>
       <p:pic>
         <p:nvPicPr>
-          <p:cNvPr id="4" name="Picture 3">
-            <a:extLst>
-              <a:ext uri="{FF2B5EF4-FFF2-40B4-BE49-F238E27FC236}">
-                <a16:creationId xmlns:a16="http://schemas.microsoft.com/office/drawing/2014/main" id="{DB3376F4-992E-E245-91FB-063D16B0794A}"/>
+          <p:cNvPr id="6" name="Picture 5">
+            <a:extLst>
+              <a:ext uri="{FF2B5EF4-FFF2-40B4-BE49-F238E27FC236}">
+                <a16:creationId xmlns:a16="http://schemas.microsoft.com/office/drawing/2014/main" id="{18C323FE-4D1A-BB46-82DC-7FAB119099BE}"/>
               </a:ext>
             </a:extLst>
           </p:cNvPr>
@@ -3495,7 +3545,7 @@
         </p:blipFill>
         <p:spPr>
           <a:xfrm>
-            <a:off x="6096000" y="375600"/>
+            <a:off x="5608047" y="852653"/>
             <a:ext cx="5715000" cy="4127500"/>
           </a:xfrm>
           <a:prstGeom prst="rect">
@@ -3506,75 +3556,12 @@
           </a:ln>
         </p:spPr>
       </p:pic>
-      <p:pic>
-        <p:nvPicPr>
-          <p:cNvPr id="6" name="Picture 5">
-            <a:extLst>
-              <a:ext uri="{FF2B5EF4-FFF2-40B4-BE49-F238E27FC236}">
-                <a16:creationId xmlns:a16="http://schemas.microsoft.com/office/drawing/2014/main" id="{18C323FE-4D1A-BB46-82DC-7FAB119099BE}"/>
-              </a:ext>
-            </a:extLst>
-          </p:cNvPr>
-          <p:cNvPicPr>
-            <a:picLocks noChangeAspect="1"/>
-          </p:cNvPicPr>
-          <p:nvPr/>
-        </p:nvPicPr>
-        <p:blipFill>
-          <a:blip r:embed="rId2"/>
-          <a:stretch>
-            <a:fillRect/>
-          </a:stretch>
-        </p:blipFill>
-        <p:spPr>
-          <a:xfrm>
-            <a:off x="517063" y="2656739"/>
-            <a:ext cx="5715000" cy="4127500"/>
-          </a:xfrm>
-          <a:prstGeom prst="rect">
-            <a:avLst/>
-          </a:prstGeom>
-          <a:ln>
-            <a:noFill/>
-          </a:ln>
-        </p:spPr>
-      </p:pic>
-      <p:pic>
-        <p:nvPicPr>
-          <p:cNvPr id="7" name="Picture 6">
-            <a:extLst>
-              <a:ext uri="{FF2B5EF4-FFF2-40B4-BE49-F238E27FC236}">
-                <a16:creationId xmlns:a16="http://schemas.microsoft.com/office/drawing/2014/main" id="{BF714CAD-66BC-D449-ABFE-19A78D75A986}"/>
-              </a:ext>
-            </a:extLst>
-          </p:cNvPr>
-          <p:cNvPicPr>
-            <a:picLocks noChangeAspect="1"/>
-          </p:cNvPicPr>
-          <p:nvPr/>
-        </p:nvPicPr>
-        <p:blipFill>
-          <a:blip r:embed="rId3"/>
-          <a:stretch>
-            <a:fillRect/>
-          </a:stretch>
-        </p:blipFill>
-        <p:spPr>
-          <a:xfrm>
-            <a:off x="5650217" y="3187380"/>
-            <a:ext cx="5708650" cy="3066218"/>
-          </a:xfrm>
-          <a:prstGeom prst="rect">
-            <a:avLst/>
-          </a:prstGeom>
-        </p:spPr>
-      </p:pic>
       <p:grpSp>
         <p:nvGrpSpPr>
-          <p:cNvPr id="2" name="Group 1">
-            <a:extLst>
-              <a:ext uri="{FF2B5EF4-FFF2-40B4-BE49-F238E27FC236}">
-                <a16:creationId xmlns:a16="http://schemas.microsoft.com/office/drawing/2014/main" id="{5DB37339-90CD-F341-9743-1E9434E55C34}"/>
+          <p:cNvPr id="3" name="Group 2">
+            <a:extLst>
+              <a:ext uri="{FF2B5EF4-FFF2-40B4-BE49-F238E27FC236}">
+                <a16:creationId xmlns:a16="http://schemas.microsoft.com/office/drawing/2014/main" id="{693B92D5-8FEF-6D47-A300-D60855E4D23F}"/>
               </a:ext>
             </a:extLst>
           </p:cNvPr>
@@ -3583,18 +3570,18 @@
         </p:nvGrpSpPr>
         <p:grpSpPr>
           <a:xfrm>
-            <a:off x="377825" y="286246"/>
-            <a:ext cx="5715000" cy="4127500"/>
-            <a:chOff x="377825" y="286246"/>
-            <a:chExt cx="5715000" cy="4127500"/>
+            <a:off x="516077" y="567475"/>
+            <a:ext cx="5715847" cy="4127500"/>
+            <a:chOff x="516077" y="567475"/>
+            <a:chExt cx="5715847" cy="4127500"/>
           </a:xfrm>
         </p:grpSpPr>
         <p:pic>
           <p:nvPicPr>
-            <p:cNvPr id="5" name="Picture 4">
+            <p:cNvPr id="13" name="Picture 12">
               <a:extLst>
                 <a:ext uri="{FF2B5EF4-FFF2-40B4-BE49-F238E27FC236}">
-                  <a16:creationId xmlns:a16="http://schemas.microsoft.com/office/drawing/2014/main" id="{B97E1878-F3A3-2142-A78F-BC612F4AC39C}"/>
+                  <a16:creationId xmlns:a16="http://schemas.microsoft.com/office/drawing/2014/main" id="{4E983617-C566-1E4A-8ED1-D5A515650ACD}"/>
                 </a:ext>
               </a:extLst>
             </p:cNvPr>
@@ -3611,7 +3598,7 @@
           </p:blipFill>
           <p:spPr>
             <a:xfrm>
-              <a:off x="377825" y="286246"/>
+              <a:off x="516924" y="567475"/>
               <a:ext cx="5715000" cy="4127500"/>
             </a:xfrm>
             <a:prstGeom prst="rect">
@@ -3624,10 +3611,10 @@
         </p:pic>
         <p:pic>
           <p:nvPicPr>
-            <p:cNvPr id="8" name="Picture 7">
+            <p:cNvPr id="14" name="Picture 13">
               <a:extLst>
                 <a:ext uri="{FF2B5EF4-FFF2-40B4-BE49-F238E27FC236}">
-                  <a16:creationId xmlns:a16="http://schemas.microsoft.com/office/drawing/2014/main" id="{41EC494D-D0C4-5C44-8FEF-75F38685B9F5}"/>
+                  <a16:creationId xmlns:a16="http://schemas.microsoft.com/office/drawing/2014/main" id="{570EC970-D75F-FD4B-BBD1-945FDBEFDC02}"/>
                 </a:ext>
               </a:extLst>
             </p:cNvPr>
@@ -3637,14 +3624,14 @@
             <p:nvPr/>
           </p:nvPicPr>
           <p:blipFill rotWithShape="1">
-            <a:blip r:embed="rId4"/>
-            <a:srcRect b="2211"/>
+            <a:blip r:embed="rId3"/>
+            <a:srcRect l="1552" b="1150"/>
             <a:stretch/>
           </p:blipFill>
           <p:spPr>
             <a:xfrm>
-              <a:off x="380999" y="658164"/>
-              <a:ext cx="5711825" cy="3135360"/>
+              <a:off x="516077" y="1025612"/>
+              <a:ext cx="5715847" cy="3231238"/>
             </a:xfrm>
             <a:prstGeom prst="rect">
               <a:avLst/>
@@ -3656,6 +3643,66 @@
     <p:extLst>
       <p:ext uri="{BB962C8B-B14F-4D97-AF65-F5344CB8AC3E}">
         <p14:creationId xmlns:p14="http://schemas.microsoft.com/office/powerpoint/2010/main" val="1127673825"/>
+      </p:ext>
+    </p:extLst>
+  </p:cSld>
+  <p:clrMapOvr>
+    <a:masterClrMapping/>
+  </p:clrMapOvr>
+</p:sld>
+</file>
+
+<file path=ppt/slides/slide3.xml><?xml version="1.0" encoding="utf-8"?>
+<p:sld xmlns:a="http://schemas.openxmlformats.org/drawingml/2006/main" xmlns:r="http://schemas.openxmlformats.org/officeDocument/2006/relationships" xmlns:p="http://schemas.openxmlformats.org/presentationml/2006/main">
+  <p:cSld>
+    <p:spTree>
+      <p:nvGrpSpPr>
+        <p:cNvPr id="1" name=""/>
+        <p:cNvGrpSpPr/>
+        <p:nvPr/>
+      </p:nvGrpSpPr>
+      <p:grpSpPr>
+        <a:xfrm>
+          <a:off x="0" y="0"/>
+          <a:ext cx="0" cy="0"/>
+          <a:chOff x="0" y="0"/>
+          <a:chExt cx="0" cy="0"/>
+        </a:xfrm>
+      </p:grpSpPr>
+      <p:pic>
+        <p:nvPicPr>
+          <p:cNvPr id="2" name="Picture 1">
+            <a:extLst>
+              <a:ext uri="{FF2B5EF4-FFF2-40B4-BE49-F238E27FC236}">
+                <a16:creationId xmlns:a16="http://schemas.microsoft.com/office/drawing/2014/main" id="{2453EA50-61CA-104F-9C49-EC825652BD7F}"/>
+              </a:ext>
+            </a:extLst>
+          </p:cNvPr>
+          <p:cNvPicPr>
+            <a:picLocks noChangeAspect="1"/>
+          </p:cNvPicPr>
+          <p:nvPr/>
+        </p:nvPicPr>
+        <p:blipFill>
+          <a:blip r:embed="rId2"/>
+          <a:stretch>
+            <a:fillRect/>
+          </a:stretch>
+        </p:blipFill>
+        <p:spPr>
+          <a:xfrm>
+            <a:off x="3175000" y="1771650"/>
+            <a:ext cx="5842000" cy="3314700"/>
+          </a:xfrm>
+          <a:prstGeom prst="rect">
+            <a:avLst/>
+          </a:prstGeom>
+        </p:spPr>
+      </p:pic>
+    </p:spTree>
+    <p:extLst>
+      <p:ext uri="{BB962C8B-B14F-4D97-AF65-F5344CB8AC3E}">
+        <p14:creationId xmlns:p14="http://schemas.microsoft.com/office/powerpoint/2010/main" val="2469253102"/>
       </p:ext>
     </p:extLst>
   </p:cSld>

</xml_diff>